<commit_message>
fix(presentacion): línea inclinada en el diagrama MCP + restaurar ficheros del kickoff
- diagrama_mcp_agentes.tex: el bucle RETRY_WITH_FIX salía con el tramo
  vertical ligeramente inclinado (los dos codos usaban el ancho de cajas
  distintas -- gate vs. el fit de las tarjetas -- que no miden exactamente
  lo mismo). Se fija un único punto de referencia para ambos codos.
- Restaura main.tex/main.pdf, malaga.jpeg, diagrama_estructura.png y los
  logos uma/google/virustotal: el `git pull --ff-only` del commit anterior
  hizo avanzar main sobre el commit de auditoría que los había borrado de
  verdad (no solo del índice), así que desaparecieron del árbol de trabajo
  como efecto colateral -- el README/GUIA_ESTILO ya los daban por existentes
  como referencia del deck de kickoff.

Co-Authored-By: Claude Sonnet 5 <noreply@anthropic.com>
</commit_message>
<xml_diff>
--- a/docs/presentacion/WatchGate_plantilla.pptx
+++ b/docs/presentacion/WatchGate_plantilla.pptx
@@ -5139,8 +5139,8 @@
         </p:blipFill>
         <p:spPr>
           <a:xfrm>
-            <a:off x="2189858" y="1444752"/>
-            <a:ext cx="7811978" cy="4937760"/>
+            <a:off x="2299134" y="1444752"/>
+            <a:ext cx="7593426" cy="4937760"/>
           </a:xfrm>
           <a:prstGeom prst="rect">
             <a:avLst/>

</xml_diff>

<commit_message>
style(presentacion): diagrama MCP/agentes más legible — nombres grandes, menos texto
Rehecho el diagrama del flujo agéntico: títulos en cuerpo grande, se quitan
las descripciones largas y los nombres completos de las tools; cada caja
queda con su icono + nombre y poco más.

Co-Authored-By: Claude Sonnet 5 <noreply@anthropic.com>
</commit_message>
<xml_diff>
--- a/docs/presentacion/WatchGate_plantilla.pptx
+++ b/docs/presentacion/WatchGate_plantilla.pptx
@@ -5139,8 +5139,8 @@
         </p:blipFill>
         <p:spPr>
           <a:xfrm>
-            <a:off x="2299134" y="1444752"/>
-            <a:ext cx="7593426" cy="4937760"/>
+            <a:off x="2617845" y="1444752"/>
+            <a:ext cx="6956005" cy="4937760"/>
           </a:xfrm>
           <a:prstGeom prst="rect">
             <a:avLst/>

</xml_diff>

<commit_message>
style(presentacion): agrandar los nombres de las tools en el diagrama MCP
Los nombres de las herramientas (precheck, analyze_diff, ...) no se leían.
Ahora van al mismo cuerpo que los títulos de banda; query_threat_kb se
abrevia a threat_kb para que quepa. El bucle RETRY_WITH_FIX pasa por fuera
de la fila de tools (ahora más ancha que las bandas) para no cruzar cajas.

Co-Authored-By: Claude Sonnet 5 <noreply@anthropic.com>
</commit_message>
<xml_diff>
--- a/docs/presentacion/WatchGate_plantilla.pptx
+++ b/docs/presentacion/WatchGate_plantilla.pptx
@@ -5139,8 +5139,8 @@
         </p:blipFill>
         <p:spPr>
           <a:xfrm>
-            <a:off x="2617845" y="1444752"/>
-            <a:ext cx="6956005" cy="4937760"/>
+            <a:off x="1986007" y="1444752"/>
+            <a:ext cx="8219680" cy="4937760"/>
           </a:xfrm>
           <a:prstGeom prst="rect">
             <a:avLst/>

</xml_diff>